<commit_message>
Update solution deck and add standalone architecture diagram
Deck: correct proof metric to 200+ sightings, soften a specific asset
count, surface OCR-tolerant search and cloned-plate detection on the
Model 2 slide, and remove a stray en-dash. Add build_diagram.js, a
one-page architecture and data-flow diagram, and regenerate both decks.

Co-Authored-By: Claude Opus 4.8 <noreply@anthropic.com>
</commit_message>
<xml_diff>
--- a/deck/netra_deck.pptx
+++ b/deck/netra_deck.pptx
@@ -4233,7 +4233,7 @@
                 <a:ea typeface="Calibri" pitchFamily="34" charset="-122"/>
                 <a:cs typeface="Calibri" pitchFamily="34" charset="-120"/>
               </a:rPr>
-              <a:t>Statewide event load (40–200k/s) is ~0.3% of the video data; a small Redpanda cluster clears it with headroom.</a:t>
+              <a:t>Statewide event load (40-200k/s) is ~0.3% of the video data; a small Redpanda cluster clears it with headroom.</a:t>
             </a:r>
             <a:endParaRPr lang="en-US" sz="1150" dirty="0"/>
           </a:p>
@@ -9476,7 +9476,7 @@
                 <a:ea typeface="Cambria" pitchFamily="34" charset="-122"/>
                 <a:cs typeface="Cambria" pitchFamily="34" charset="-120"/>
               </a:rPr>
-              <a:t>300</a:t>
+              <a:t>200+</a:t>
             </a:r>
             <a:endParaRPr lang="en-US" sz="3200" dirty="0"/>
           </a:p>
@@ -12962,7 +12962,7 @@
                 <a:ea typeface="Calibri" pitchFamily="34" charset="-122"/>
                 <a:cs typeface="Calibri" pitchFamily="34" charset="-120"/>
               </a:rPr>
-              <a:t>Make, model, install date, AMC and EOL per camera - 17 maintenance-due and 12 end-of-life surfaced automatically.</a:t>
+              <a:t>Make, model, install date, AMC and EOL per camera; maintenance-due and end-of-life items are surfaced automatically.</a:t>
             </a:r>
             <a:endParaRPr lang="en-US" sz="1200" dirty="0"/>
           </a:p>
@@ -14390,7 +14390,7 @@
                 <a:ea typeface="Calibri" pitchFamily="34" charset="-122"/>
                 <a:cs typeface="Calibri" pitchFamily="34" charset="-120"/>
               </a:rPr>
-              <a:t>Searchable plate + camera-wise indexing feed cross-camera route reconstruction and boxed watchlist (BOLO) alerts.</a:t>
+              <a:t>Tolerant plate search (OCR-error aware) drives cross-camera routes, watchlist (BOLO) matches, and cloned-plate detection across systems.</a:t>
             </a:r>
             <a:endParaRPr lang="en-US" sz="1200" dirty="0"/>
           </a:p>

</xml_diff>